<commit_message>
Sahoshi: Deck and evidence rebuilt: decider v1.2 row, speech re-run, live road-state still; slide 8 title on one line
</commit_message>
<xml_diff>
--- a/docs/deck/Sahoshi_Deck.pptx
+++ b/docs/deck/Sahoshi_Deck.pptx
@@ -8645,8 +8645,8 @@
         </p:blipFill>
         <p:spPr>
           <a:xfrm>
-            <a:off x="6940296" y="1737360"/>
-            <a:ext cx="3950207" cy="3429000"/>
+            <a:off x="7045036" y="1737360"/>
+            <a:ext cx="3740727" cy="3428999"/>
           </a:xfrm>
           <a:prstGeom prst="rect">
             <a:avLst/>
@@ -9293,7 +9293,7 @@
                 <a:latin typeface="Inter"/>
                 <a:cs typeface="Noto Sans Bengali"/>
               </a:rPr>
-              <a:t>2025–26 open-source models, all on one computer in the control room</a:t>
+              <a:t>2025–26 open models on one control-room computer</a:t>
             </a:r>
           </a:p>
         </p:txBody>
@@ -9949,7 +9949,7 @@
                 <a:latin typeface="Inter"/>
                 <a:cs typeface="Noto Sans Bengali"/>
               </a:rPr>
-              <a:t>11.5% word error, place matched 53/60 (synthetic round trip)</a:t>
+              <a:t>11.2% word error, place matched 55/60 (synthetic round trip)</a:t>
             </a:r>
           </a:p>
         </p:txBody>
@@ -10197,7 +10197,7 @@
                 <a:latin typeface="Inter"/>
                 <a:cs typeface="Noto Sans Bengali"/>
               </a:rPr>
-              <a:t>Assistant</a:t>
+              <a:t>Decision</a:t>
             </a:r>
           </a:p>
         </p:txBody>
@@ -10237,7 +10237,7 @@
                 <a:latin typeface="Inter"/>
                 <a:cs typeface="Noto Sans Bengali"/>
               </a:rPr>
-              <a:t>Local Gemma-class LLM + retrieval</a:t>
+              <a:t>pplx-decider-v1.2 (27B) + Gemma 4</a:t>
             </a:r>
           </a:p>
         </p:txBody>
@@ -10277,7 +10277,7 @@
                 <a:latin typeface="Inter"/>
                 <a:cs typeface="Noto Sans Bengali"/>
               </a:rPr>
-              <a:t>Answers grounded in the live picture; numbers checked against tool results</a:t>
+              <a:t>Typed answers in 1.0 s; 22 of 26 labelled Kolkata decisions; an officer approves every action</a:t>
             </a:r>
           </a:p>
         </p:txBody>

</xml_diff>

<commit_message>
Sahoshi: AI4Bharat Indic Parler-TTS is the live Bengali voice (round-trip places 60/60), one loudness for every voice; IndicConformer measured and kept out; 6,030 Python tests
</commit_message>
<xml_diff>
--- a/docs/deck/Sahoshi_Deck.pptx
+++ b/docs/deck/Sahoshi_Deck.pptx
@@ -9909,7 +9909,7 @@
                 <a:latin typeface="Inter"/>
                 <a:cs typeface="Noto Sans Bengali"/>
               </a:rPr>
-              <a:t>Bengali Whisper (Apache-2.0), Svara-TTS</a:t>
+              <a:t>Bengali Whisper + Indic Parler-TTS (Apache-2.0)</a:t>
             </a:r>
           </a:p>
         </p:txBody>
@@ -9949,7 +9949,7 @@
                 <a:latin typeface="Inter"/>
                 <a:cs typeface="Noto Sans Bengali"/>
               </a:rPr>
-              <a:t>11.2% word error, place matched 55/60 (synthetic round trip)</a:t>
+              <a:t>11.2% word error, place 55/60; voice: places 60/60 (round trip)</a:t>
             </a:r>
           </a:p>
         </p:txBody>

</xml_diff>

<commit_message>
Neutral look and English-first everywhere; a dense, live map (roads by V/C with flow, 191 labelled places, live values, 18 emulated units); every earlier capability verified and the procession class added; OSINT scope gate (no crime, clashes or politics); 36 new screenshots placed through the docs; 69/69 gates, 6,310 Python + 121 Rust tests
</commit_message>
<xml_diff>
--- a/docs/deck/Sahoshi_Deck.pptx
+++ b/docs/deck/Sahoshi_Deck.pptx
@@ -3195,7 +3195,7 @@
         <p:spPr>
           <a:xfrm>
             <a:off x="548640" y="822960"/>
-            <a:ext cx="2804591" cy="566928"/>
+            <a:ext cx="1706880" cy="566928"/>
           </a:xfrm>
           <a:prstGeom prst="rect">
             <a:avLst/>
@@ -3226,35 +3226,35 @@
           <a:p>
             <a:pPr algn="l">
               <a:spcAft>
-                <a:spcPts val="2430"/>
-              </a:spcAft>
-            </a:pPr>
-            <a:r>
-              <a:rPr sz="5400" b="1" i="0">
+                <a:spcPts val="2070"/>
+              </a:spcAft>
+            </a:pPr>
+            <a:r>
+              <a:rPr sz="4600" b="1" i="0">
                 <a:solidFill>
                   <a:srgbClr val="FFFFFF"/>
                 </a:solidFill>
                 <a:latin typeface="Inter"/>
                 <a:cs typeface="Noto Sans Bengali"/>
               </a:rPr>
-              <a:t>থামিয়ে নয়,</a:t>
-            </a:r>
-          </a:p>
-          <a:p>
-            <a:pPr algn="l">
-              <a:spcAft>
-                <a:spcPts val="2430"/>
-              </a:spcAft>
-            </a:pPr>
-            <a:r>
-              <a:rPr sz="5400" b="1" i="0">
-                <a:solidFill>
-                  <a:srgbClr val="FFC800"/>
-                </a:solidFill>
-                <a:latin typeface="Inter"/>
-                <a:cs typeface="Noto Sans Bengali"/>
-              </a:rPr>
-              <a:t>সামলে।</a:t>
+              <a:t>Not by stopping.</a:t>
+            </a:r>
+          </a:p>
+          <a:p>
+            <a:pPr algn="l">
+              <a:spcAft>
+                <a:spcPts val="2070"/>
+              </a:spcAft>
+            </a:pPr>
+            <a:r>
+              <a:rPr sz="4600" b="1" i="0">
+                <a:solidFill>
+                  <a:srgbClr val="A6A6A6"/>
+                </a:solidFill>
+                <a:latin typeface="Inter"/>
+                <a:cs typeface="Noto Sans Bengali"/>
+              </a:rPr>
+              <a:t>By steering.</a:t>
             </a:r>
           </a:p>
         </p:txBody>
@@ -4153,7 +4153,7 @@
                 <a:latin typeface="Inter"/>
                 <a:cs typeface="Noto Sans Bengali"/>
               </a:rPr>
-              <a:t>  ·  সাহসী  ·  Kolkata</a:t>
+              <a:t>  ·  Kolkata</a:t>
             </a:r>
           </a:p>
         </p:txBody>
@@ -4935,7 +4935,7 @@
                 <a:latin typeface="Inter"/>
                 <a:cs typeface="Noto Sans Bengali"/>
               </a:rPr>
-              <a:t>  ·  সাহসী  ·  Kolkata</a:t>
+              <a:t>  ·  Kolkata</a:t>
             </a:r>
           </a:p>
         </p:txBody>
@@ -5609,7 +5609,7 @@
                 <a:latin typeface="Inter"/>
                 <a:cs typeface="Noto Sans Bengali"/>
               </a:rPr>
-              <a:t>  ·  সাহসী  ·  Kolkata</a:t>
+              <a:t>  ·  Kolkata</a:t>
             </a:r>
           </a:p>
         </p:txBody>
@@ -6097,7 +6097,7 @@
                 <a:latin typeface="Inter"/>
                 <a:cs typeface="Noto Sans Bengali"/>
               </a:rPr>
-              <a:t>  ·  সাহসী  ·  Kolkata</a:t>
+              <a:t>  ·  Kolkata</a:t>
             </a:r>
           </a:p>
         </p:txBody>
@@ -6256,7 +6256,7 @@
         <p:spPr>
           <a:xfrm>
             <a:off x="4956048" y="1280160"/>
-            <a:ext cx="1152000" cy="1463040"/>
+            <a:ext cx="1518727" cy="1463040"/>
           </a:xfrm>
           <a:prstGeom prst="rect">
             <a:avLst/>
@@ -6271,8 +6271,8 @@
         </p:nvSpPr>
         <p:spPr>
           <a:xfrm>
-            <a:off x="1371600" y="3154680"/>
-            <a:ext cx="9445752" cy="1280160"/>
+            <a:off x="1371600" y="3246120"/>
+            <a:ext cx="9445752" cy="1828800"/>
           </a:xfrm>
           <a:prstGeom prst="rect">
             <a:avLst/>
@@ -6298,7 +6298,24 @@
                 <a:latin typeface="Inter"/>
                 <a:cs typeface="Noto Sans Bengali"/>
               </a:rPr>
-              <a:t>ধন্যবাদ</a:t>
+              <a:t>Thank you</a:t>
+            </a:r>
+          </a:p>
+          <a:p>
+            <a:pPr algn="ctr">
+              <a:spcAft>
+                <a:spcPts val="630"/>
+              </a:spcAft>
+            </a:pPr>
+            <a:r>
+              <a:rPr sz="1400" b="0" i="0">
+                <a:solidFill>
+                  <a:srgbClr val="CBCBCB"/>
+                </a:solidFill>
+                <a:latin typeface="Inter"/>
+                <a:cs typeface="Noto Sans Bengali"/>
+              </a:rPr>
+              <a:t>github.com/shubro18202758/sahoshi</a:t>
             </a:r>
           </a:p>
         </p:txBody>
@@ -6306,63 +6323,6 @@
       <p:sp>
         <p:nvSpPr>
           <p:cNvPr id="6" name="TextBox 5"/>
-          <p:cNvSpPr txBox="1"/>
-          <p:nvPr/>
-        </p:nvSpPr>
-        <p:spPr>
-          <a:xfrm>
-            <a:off x="1371600" y="4251960"/>
-            <a:ext cx="9445752" cy="1280160"/>
-          </a:xfrm>
-          <a:prstGeom prst="rect">
-            <a:avLst/>
-          </a:prstGeom>
-          <a:noFill/>
-        </p:spPr>
-        <p:txBody>
-          <a:bodyPr wrap="square" anchor="t" lIns="0" rIns="0" tIns="0" bIns="0">
-            <a:spAutoFit/>
-          </a:bodyPr>
-          <a:lstStyle/>
-          <a:p>
-            <a:pPr algn="ctr">
-              <a:spcAft>
-                <a:spcPts val="1170"/>
-              </a:spcAft>
-            </a:pPr>
-            <a:r>
-              <a:rPr sz="2600" b="1" i="0">
-                <a:solidFill>
-                  <a:srgbClr val="FFFFFF"/>
-                </a:solidFill>
-                <a:latin typeface="Inter"/>
-                <a:cs typeface="Noto Sans Bengali"/>
-              </a:rPr>
-              <a:t>Thank you</a:t>
-            </a:r>
-          </a:p>
-          <a:p>
-            <a:pPr algn="ctr">
-              <a:spcAft>
-                <a:spcPts val="630"/>
-              </a:spcAft>
-            </a:pPr>
-            <a:r>
-              <a:rPr sz="1400" b="0" i="0">
-                <a:solidFill>
-                  <a:srgbClr val="CBCBCB"/>
-                </a:solidFill>
-                <a:latin typeface="Inter"/>
-                <a:cs typeface="Noto Sans Bengali"/>
-              </a:rPr>
-              <a:t>github.com/shubro18202758/sahoshi</a:t>
-            </a:r>
-          </a:p>
-        </p:txBody>
-      </p:sp>
-      <p:sp>
-        <p:nvSpPr>
-          <p:cNvPr id="7" name="TextBox 6"/>
           <p:cNvSpPr txBox="1"/>
           <p:nvPr/>
         </p:nvSpPr>
@@ -7157,7 +7117,7 @@
                 <a:latin typeface="Inter"/>
                 <a:cs typeface="Noto Sans Bengali"/>
               </a:rPr>
-              <a:t>  ·  সাহসী  ·  Kolkata</a:t>
+              <a:t>  ·  Kolkata</a:t>
             </a:r>
           </a:p>
         </p:txBody>
@@ -7303,7 +7263,7 @@
                 <a:latin typeface="Inter"/>
                 <a:cs typeface="Noto Sans Bengali"/>
               </a:rPr>
-              <a:t>See · Decide · Act — one shared, Bengali-first picture</a:t>
+              <a:t>See · Decide · Act — one shared picture</a:t>
             </a:r>
           </a:p>
         </p:txBody>
@@ -7707,7 +7667,7 @@
                 <a:latin typeface="Inter"/>
                 <a:cs typeface="Noto Sans Bengali"/>
               </a:rPr>
-              <a:t>A named officer approves or rejects — nothing acts on its own; no answer, the plan holds. Advisories go out in বাংলা, English and हिंदी, read aloud.</a:t>
+              <a:t>A named officer approves or rejects — nothing acts on its own; no answer, the plan holds. Advisories go out in English, Bengali and Hindi, read aloud.</a:t>
             </a:r>
           </a:p>
         </p:txBody>
@@ -7781,7 +7741,7 @@
                 <a:latin typeface="Inter"/>
                 <a:cs typeface="Noto Sans Bengali"/>
               </a:rPr>
-              <a:t>  ·  সাহসী  ·  Kolkata</a:t>
+              <a:t>  ·  Kolkata</a:t>
             </a:r>
           </a:p>
         </p:txBody>
@@ -8109,7 +8069,7 @@
                 <a:latin typeface="Inter"/>
                 <a:cs typeface="Noto Sans Bengali"/>
               </a:rPr>
-              <a:t>  ·  সাহসী  ·  Kolkata</a:t>
+              <a:t>  ·  Kolkata</a:t>
             </a:r>
           </a:p>
         </p:txBody>
@@ -8454,7 +8414,7 @@
                 <a:latin typeface="Inter"/>
                 <a:cs typeface="Noto Sans Bengali"/>
               </a:rPr>
-              <a:t>  ·  সাহসী  ·  Kolkata</a:t>
+              <a:t>  ·  Kolkata</a:t>
             </a:r>
           </a:p>
         </p:txBody>
@@ -8600,7 +8560,7 @@
                 <a:latin typeface="Inter"/>
                 <a:cs typeface="Noto Sans Bengali"/>
               </a:rPr>
-              <a:t>Bengali voice reports and camera road state</a:t>
+              <a:t>Voice reports and camera road state</a:t>
             </a:r>
           </a:p>
         </p:txBody>
@@ -8688,7 +8648,7 @@
                 <a:latin typeface="Inter"/>
                 <a:cs typeface="Noto Sans Bengali"/>
               </a:rPr>
-              <a:t>An officer speaks in Bengali; the on-premises speech model returns place · kind · severity with the transcript — an unverified field report for a named officer to confirm. Audio is not stored.</a:t>
+              <a:t>An officer speaks in English, Bengali or Hindi; the on-premises speech model returns place · kind · severity with the transcript — an unverified field report for a named officer to confirm. Audio is not stored.</a:t>
             </a:r>
           </a:p>
         </p:txBody>
@@ -8778,7 +8738,7 @@
                 <a:latin typeface="Inter"/>
                 <a:cs typeface="Noto Sans Bengali"/>
               </a:rPr>
-              <a:t>  ·  সাহসী  ·  Kolkata</a:t>
+              <a:t>  ·  Kolkata</a:t>
             </a:r>
           </a:p>
         </p:txBody>
@@ -8924,7 +8884,7 @@
                 <a:latin typeface="Inter"/>
                 <a:cs typeface="Noto Sans Bengali"/>
               </a:rPr>
-              <a:t>Check your road — in বাংলা, read aloud</a:t>
+              <a:t>Check your road, read aloud</a:t>
             </a:r>
           </a:p>
         </p:txBody>
@@ -9029,7 +8989,7 @@
                 <a:latin typeface="Inter"/>
                 <a:cs typeface="Noto Sans Bengali"/>
               </a:rPr>
-              <a:t>Waterlogging on your road, the tide and the rain, holds and diversions — in বাংলা, English and हिंदी, with a Listen button (synthetic voice).</a:t>
+              <a:t>Waterlogging on your road, the tide and the rain, holds and diversions — in English, Bengali and Hindi, with a Listen button (synthetic voice).</a:t>
             </a:r>
           </a:p>
           <a:p>
@@ -9147,7 +9107,7 @@
                 <a:latin typeface="Inter"/>
                 <a:cs typeface="Noto Sans Bengali"/>
               </a:rPr>
-              <a:t>  ·  সাহসী  ·  Kolkata</a:t>
+              <a:t>  ·  Kolkata</a:t>
             </a:r>
           </a:p>
         </p:txBody>
@@ -10367,7 +10327,7 @@
                 <a:latin typeface="Inter"/>
                 <a:cs typeface="Noto Sans Bengali"/>
               </a:rPr>
-              <a:t>  ·  সাহসী  ·  Kolkata</a:t>
+              <a:t>  ·  Kolkata</a:t>
             </a:r>
           </a:p>
         </p:txBody>
@@ -11007,7 +10967,7 @@
                 <a:latin typeface="Inter"/>
                 <a:cs typeface="Noto Sans Bengali"/>
               </a:rPr>
-              <a:t>  ·  সাহসী  ·  Kolkata</a:t>
+              <a:t>  ·  Kolkata</a:t>
             </a:r>
           </a:p>
         </p:txBody>

</xml_diff>